<commit_message>
paper: update for 0.9 (JOSS pre-review)
- Graphical abstract: runnable 0.9 code strip (neutral fragments scored
  against the decharged spectrum), cards for mzSpecLib, publication
  figures, TMT/iTRAQ reporter ions and interoperability.
- Text: publication-figure layer, tacular dependency, reporter-ion
  quantification, mzSpecLib and mzPAF writers, indexed spectrum lookup
  (Sage scannr), similarity metrics and USI fetch.
- Bib: sibling packages cite Zenodo concept DOIs with current titles;
  add tacular, Matplotlib, TMT, iTRAQ, Sage, spectral entropy and
  modified-cosine references.
- Date 24 September 2026; AI disclosure flagged TODO(author).

Co-Authored-By: Claude Opus 5.5 (1M context) <noreply@anthropic.com>
</commit_message>
<xml_diff>
--- a/paper/spxtacular_graphical_abstract.pptx
+++ b/paper/spxtacular_graphical_abstract.pptx
@@ -1848,7 +1848,7 @@
         <p:spPr>
           <a:xfrm xmlns:a="http://schemas.openxmlformats.org/drawingml/2006/main">
             <a:off x="502920" y="3478485"/>
-            <a:ext cx="11183112" cy="475488"/>
+            <a:ext cx="11183112" cy="640080"/>
           </a:xfrm>
           <a:prstGeom xmlns:a="http://schemas.openxmlformats.org/drawingml/2006/main" prst="roundRect">
             <a:avLst>
@@ -1877,7 +1877,242 @@
         <p:spPr>
           <a:xfrm xmlns:a="http://schemas.openxmlformats.org/drawingml/2006/main">
             <a:off x="502920" y="3478485"/>
-            <a:ext cx="11183112" cy="475488"/>
+            <a:ext cx="11183112" cy="640080"/>
+          </a:xfrm>
+          <a:prstGeom xmlns:a="http://schemas.openxmlformats.org/drawingml/2006/main" prst="rect">
+            <a:avLst/>
+          </a:prstGeom>
+          <a:noFill xmlns:a="http://schemas.openxmlformats.org/drawingml/2006/main"/>
+        </p:spPr>
+        <p:txBody>
+          <a:bodyPr xmlns:a="http://schemas.openxmlformats.org/drawingml/2006/main" wrap="square" lIns="1645920" tIns="0" rIns="0" bIns="0" anchor="ctr"/>
+          <a:lstStyle xmlns:a="http://schemas.openxmlformats.org/drawingml/2006/main"/>
+          <a:p xmlns:a="http://schemas.openxmlformats.org/drawingml/2006/main">
+            <a:pPr marL="0" indent="0" algn="l">
+              <a:buNone/>
+            </a:pPr>
+            <a:r>
+              <a:rPr sz="1250">
+                <a:solidFill>
+                  <a:srgbClr val="1A1A1A"/>
+                </a:solidFill>
+                <a:latin typeface="Courier New"/>
+                <a:ea typeface="Courier New"/>
+                <a:cs typeface="Courier New"/>
+              </a:rPr>
+              <a:t>frags = pt</a:t>
+            </a:r>
+            <a:r>
+              <a:rPr sz="1250" b="1">
+                <a:solidFill>
+                  <a:srgbClr val="0061FF"/>
+                </a:solidFill>
+                <a:latin typeface="Courier New"/>
+                <a:ea typeface="Courier New"/>
+                <a:cs typeface="Courier New"/>
+              </a:rPr>
+              <a:t>.fragment</a:t>
+            </a:r>
+            <a:r>
+              <a:rPr sz="1250">
+                <a:solidFill>
+                  <a:srgbClr val="555555"/>
+                </a:solidFill>
+                <a:latin typeface="Courier New"/>
+                <a:ea typeface="Courier New"/>
+                <a:cs typeface="Courier New"/>
+              </a:rPr>
+              <a:t>("PEPTIDEK", ion_types=("b", "y"), charges=(0,))</a:t>
+            </a:r>
+            <a:endParaRPr sz="1250"/>
+          </a:p>
+          <a:p xmlns:a="http://schemas.openxmlformats.org/drawingml/2006/main">
+            <a:pPr marL="0" indent="0" algn="l">
+              <a:buNone/>
+            </a:pPr>
+            <a:r>
+              <a:rPr sz="1250">
+                <a:solidFill>
+                  <a:srgbClr val="1A1A1A"/>
+                </a:solidFill>
+                <a:latin typeface="Courier New"/>
+                <a:ea typeface="Courier New"/>
+                <a:cs typeface="Courier New"/>
+              </a:rPr>
+              <a:t>spec</a:t>
+            </a:r>
+            <a:r>
+              <a:rPr sz="1250" b="1">
+                <a:solidFill>
+                  <a:srgbClr val="0061FF"/>
+                </a:solidFill>
+                <a:latin typeface="Courier New"/>
+                <a:ea typeface="Courier New"/>
+                <a:cs typeface="Courier New"/>
+              </a:rPr>
+              <a:t>.denoise</a:t>
+            </a:r>
+            <a:r>
+              <a:rPr sz="1250">
+                <a:solidFill>
+                  <a:srgbClr val="555555"/>
+                </a:solidFill>
+                <a:latin typeface="Courier New"/>
+                <a:ea typeface="Courier New"/>
+                <a:cs typeface="Courier New"/>
+              </a:rPr>
+              <a:t>(method="mad")</a:t>
+            </a:r>
+            <a:r>
+              <a:rPr sz="1250" b="1">
+                <a:solidFill>
+                  <a:srgbClr val="0061FF"/>
+                </a:solidFill>
+                <a:latin typeface="Courier New"/>
+                <a:ea typeface="Courier New"/>
+                <a:cs typeface="Courier New"/>
+              </a:rPr>
+              <a:t>.deconvolute</a:t>
+            </a:r>
+            <a:r>
+              <a:rPr sz="1250">
+                <a:solidFill>
+                  <a:srgbClr val="555555"/>
+                </a:solidFill>
+                <a:latin typeface="Courier New"/>
+                <a:ea typeface="Courier New"/>
+                <a:cs typeface="Courier New"/>
+              </a:rPr>
+              <a:t>(charge_range=(1, 5))</a:t>
+            </a:r>
+            <a:r>
+              <a:rPr sz="1250" b="1">
+                <a:solidFill>
+                  <a:srgbClr val="0061FF"/>
+                </a:solidFill>
+                <a:latin typeface="Courier New"/>
+                <a:ea typeface="Courier New"/>
+                <a:cs typeface="Courier New"/>
+              </a:rPr>
+              <a:t>.decharge</a:t>
+            </a:r>
+            <a:r>
+              <a:rPr sz="1250">
+                <a:solidFill>
+                  <a:srgbClr val="555555"/>
+                </a:solidFill>
+                <a:latin typeface="Courier New"/>
+                <a:ea typeface="Courier New"/>
+                <a:cs typeface="Courier New"/>
+              </a:rPr>
+              <a:t>()</a:t>
+            </a:r>
+            <a:r>
+              <a:rPr sz="1250" b="1">
+                <a:solidFill>
+                  <a:srgbClr val="0061FF"/>
+                </a:solidFill>
+                <a:latin typeface="Courier New"/>
+                <a:ea typeface="Courier New"/>
+                <a:cs typeface="Courier New"/>
+              </a:rPr>
+              <a:t>.score</a:t>
+            </a:r>
+            <a:r>
+              <a:rPr sz="1250">
+                <a:solidFill>
+                  <a:srgbClr val="555555"/>
+                </a:solidFill>
+                <a:latin typeface="Courier New"/>
+                <a:ea typeface="Courier New"/>
+                <a:cs typeface="Courier New"/>
+              </a:rPr>
+              <a:t>(frags)</a:t>
+            </a:r>
+            <a:endParaRPr sz="1250"/>
+          </a:p>
+        </p:txBody>
+      </p:sp>
+      <p:sp>
+        <p:nvSpPr>
+          <p:cNvPr id="70" name="Shape 15"/>
+          <p:cNvSpPr>
+            <a:spLocks xmlns:a="http://schemas.openxmlformats.org/drawingml/2006/main" noGrp="1"/>
+          </p:cNvSpPr>
+          <p:nvPr/>
+        </p:nvSpPr>
+        <p:spPr>
+          <a:xfrm xmlns:a="http://schemas.openxmlformats.org/drawingml/2006/main">
+            <a:off x="502920" y="4480560"/>
+            <a:ext cx="2090318" cy="1691640"/>
+          </a:xfrm>
+          <a:prstGeom xmlns:a="http://schemas.openxmlformats.org/drawingml/2006/main" prst="roundRect">
+            <a:avLst>
+              <a:gd name="adj" fmla="val 4865"/>
+            </a:avLst>
+          </a:prstGeom>
+          <a:solidFill xmlns:a="http://schemas.openxmlformats.org/drawingml/2006/main">
+            <a:srgbClr val="F3F4F6"/>
+          </a:solidFill>
+        </p:spPr>
+      </p:sp>
+      <p:sp>
+        <p:nvSpPr>
+          <p:cNvPr id="71" name="Shape 16"/>
+          <p:cNvSpPr>
+            <a:spLocks xmlns:a="http://schemas.openxmlformats.org/drawingml/2006/main" noGrp="1"/>
+          </p:cNvSpPr>
+          <p:nvPr/>
+        </p:nvSpPr>
+        <p:spPr>
+          <a:xfrm xmlns:a="http://schemas.openxmlformats.org/drawingml/2006/main">
+            <a:off x="1310335" y="4663440"/>
+            <a:ext cx="475488" cy="475488"/>
+          </a:xfrm>
+          <a:prstGeom xmlns:a="http://schemas.openxmlformats.org/drawingml/2006/main" prst="ellipse">
+            <a:avLst/>
+          </a:prstGeom>
+          <a:solidFill xmlns:a="http://schemas.openxmlformats.org/drawingml/2006/main">
+            <a:srgbClr val="FFFFFF"/>
+          </a:solidFill>
+        </p:spPr>
+      </p:sp>
+      <p:pic>
+        <p:nvPicPr>
+          <p:cNvPr id="72" name="Image 5"/>
+          <p:cNvPicPr>
+            <a:picLocks xmlns:a="http://schemas.openxmlformats.org/drawingml/2006/main" noChangeAspect="1"/>
+          </p:cNvPicPr>
+          <p:nvPr/>
+        </p:nvPicPr>
+        <p:blipFill>
+          <a:blip xmlns:r="http://schemas.openxmlformats.org/officeDocument/2006/relationships" xmlns:a="http://schemas.openxmlformats.org/drawingml/2006/main" r:embed="Rf07e9f72e881483a"/>
+          <a:stretch xmlns:a="http://schemas.openxmlformats.org/drawingml/2006/main">
+            <a:fillRect l="0" t="0" r="0" b="0"/>
+          </a:stretch>
+        </p:blipFill>
+        <p:spPr>
+          <a:xfrm xmlns:a="http://schemas.openxmlformats.org/drawingml/2006/main">
+            <a:off x="1420063" y="4773168"/>
+            <a:ext cx="256032" cy="256032"/>
+          </a:xfrm>
+          <a:prstGeom xmlns:a="http://schemas.openxmlformats.org/drawingml/2006/main" prst="rect">
+            <a:avLst/>
+          </a:prstGeom>
+        </p:spPr>
+      </p:pic>
+      <p:sp>
+        <p:nvSpPr>
+          <p:cNvPr id="73" name="Text 17"/>
+          <p:cNvSpPr>
+            <a:spLocks xmlns:a="http://schemas.openxmlformats.org/drawingml/2006/main" noGrp="1"/>
+          </p:cNvSpPr>
+          <p:nvPr/>
+        </p:nvSpPr>
+        <p:spPr>
+          <a:xfrm xmlns:a="http://schemas.openxmlformats.org/drawingml/2006/main">
+            <a:off x="557784" y="5212080"/>
+            <a:ext cx="1980590" cy="274320"/>
           </a:xfrm>
           <a:prstGeom xmlns:a="http://schemas.openxmlformats.org/drawingml/2006/main" prst="rect">
             <a:avLst/>
@@ -1892,274 +2127,32 @@
               <a:buNone/>
             </a:pPr>
             <a:r>
-              <a:rPr sz="1250">
+              <a:rPr sz="1300" b="1">
                 <a:solidFill>
                   <a:srgbClr val="1A1A1A"/>
                 </a:solidFill>
-                <a:latin typeface="Courier New"/>
-                <a:ea typeface="Courier New"/>
-                <a:cs typeface="Courier New"/>
-              </a:rPr>
-              <a:t>spec</a:t>
-            </a:r>
-            <a:r>
-              <a:rPr sz="1250" b="1">
-                <a:solidFill>
-                  <a:srgbClr val="0061FF"/>
-                </a:solidFill>
-                <a:latin typeface="Courier New"/>
-                <a:ea typeface="Courier New"/>
-                <a:cs typeface="Courier New"/>
-              </a:rPr>
-              <a:t>.denoise</a:t>
-            </a:r>
-            <a:r>
-              <a:rPr sz="1250">
-                <a:solidFill>
-                  <a:srgbClr val="555555"/>
-                </a:solidFill>
-                <a:latin typeface="Courier New"/>
-                <a:ea typeface="Courier New"/>
-                <a:cs typeface="Courier New"/>
-              </a:rPr>
-              <a:t>(method="mad")</a:t>
-            </a:r>
-            <a:r>
-              <a:rPr sz="1250" b="1">
-                <a:solidFill>
-                  <a:srgbClr val="0061FF"/>
-                </a:solidFill>
-                <a:latin typeface="Courier New"/>
-                <a:ea typeface="Courier New"/>
-                <a:cs typeface="Courier New"/>
-              </a:rPr>
-              <a:t>.deconvolute</a:t>
-            </a:r>
-            <a:r>
-              <a:rPr sz="1250">
-                <a:solidFill>
-                  <a:srgbClr val="555555"/>
-                </a:solidFill>
-                <a:latin typeface="Courier New"/>
-                <a:ea typeface="Courier New"/>
-                <a:cs typeface="Courier New"/>
-              </a:rPr>
-              <a:t>(charge_range=(1,5))</a:t>
-            </a:r>
-            <a:r>
-              <a:rPr sz="1250" b="1">
-                <a:solidFill>
-                  <a:srgbClr val="0061FF"/>
-                </a:solidFill>
-                <a:latin typeface="Courier New"/>
-                <a:ea typeface="Courier New"/>
-                <a:cs typeface="Courier New"/>
-              </a:rPr>
-              <a:t>.decharge</a:t>
-            </a:r>
-            <a:r>
-              <a:rPr sz="1250">
-                <a:solidFill>
-                  <a:srgbClr val="555555"/>
-                </a:solidFill>
-                <a:latin typeface="Courier New"/>
-                <a:ea typeface="Courier New"/>
-                <a:cs typeface="Courier New"/>
-              </a:rPr>
-              <a:t>()</a:t>
-            </a:r>
-            <a:r>
-              <a:rPr sz="1250" b="1">
-                <a:solidFill>
-                  <a:srgbClr val="0061FF"/>
-                </a:solidFill>
-                <a:latin typeface="Courier New"/>
-                <a:ea typeface="Courier New"/>
-                <a:cs typeface="Courier New"/>
-              </a:rPr>
-              <a:t>.match_fragments</a:t>
-            </a:r>
-            <a:r>
-              <a:rPr sz="1250">
-                <a:solidFill>
-                  <a:srgbClr val="555555"/>
-                </a:solidFill>
-                <a:latin typeface="Courier New"/>
-                <a:ea typeface="Courier New"/>
-                <a:cs typeface="Courier New"/>
-              </a:rPr>
-              <a:t>()</a:t>
-            </a:r>
-            <a:r>
-              <a:rPr sz="1250" b="1">
-                <a:solidFill>
-                  <a:srgbClr val="0061FF"/>
-                </a:solidFill>
-                <a:latin typeface="Courier New"/>
-                <a:ea typeface="Courier New"/>
-                <a:cs typeface="Courier New"/>
-              </a:rPr>
-              <a:t>.score</a:t>
-            </a:r>
-            <a:r>
-              <a:rPr sz="1250">
-                <a:solidFill>
-                  <a:srgbClr val="555555"/>
-                </a:solidFill>
-                <a:latin typeface="Courier New"/>
-                <a:ea typeface="Courier New"/>
-                <a:cs typeface="Courier New"/>
-              </a:rPr>
-              <a:t>()</a:t>
-            </a:r>
-            <a:endParaRPr sz="1250"/>
+                <a:latin typeface="Arial"/>
+                <a:ea typeface="Arial"/>
+                <a:cs typeface="Arial"/>
+              </a:rPr>
+              <a:t>File readers</a:t>
+            </a:r>
+            <a:endParaRPr sz="1300"/>
           </a:p>
         </p:txBody>
       </p:sp>
       <p:sp>
         <p:nvSpPr>
-          <p:cNvPr id="22" name="Shape 15">
-            <a:extLst xmlns:a="http://schemas.openxmlformats.org/drawingml/2006/main">
-              <a:ext uri="{FF2B5EF4-FFF2-40B4-BE49-F238E27FC236}">
-                <a16:creationId xmlns:a16="http://schemas.microsoft.com/office/drawing/2014/main" id="{BAAA67D8-E670-46A2-95BD-D2BCEA5928FA}"/>
-              </a:ext>
-            </a:extLst>
-          </p:cNvPr>
-          <p:cNvSpPr>
-            <a:spLocks xmlns:a="http://schemas.openxmlformats.org/drawingml/2006/main" noGrp="1"/>
-          </p:cNvSpPr>
-          <p:nvPr/>
-        </p:nvSpPr>
-        <p:spPr>
-          <a:xfrm xmlns:a="http://schemas.openxmlformats.org/drawingml/2006/main">
-            <a:off x="502920" y="4315968"/>
-            <a:ext cx="2587752" cy="1691640"/>
-          </a:xfrm>
-          <a:prstGeom xmlns:a="http://schemas.openxmlformats.org/drawingml/2006/main" prst="roundRect">
-            <a:avLst>
-              <a:gd name="adj" fmla="val 4865"/>
-            </a:avLst>
-          </a:prstGeom>
-          <a:solidFill xmlns:a="http://schemas.openxmlformats.org/drawingml/2006/main">
-            <a:srgbClr val="F3F4F6"/>
-          </a:solidFill>
-        </p:spPr>
-      </p:sp>
-      <p:sp>
-        <p:nvSpPr>
-          <p:cNvPr id="23" name="Shape 16">
-            <a:extLst xmlns:a="http://schemas.openxmlformats.org/drawingml/2006/main">
-              <a:ext uri="{FF2B5EF4-FFF2-40B4-BE49-F238E27FC236}">
-                <a16:creationId xmlns:a16="http://schemas.microsoft.com/office/drawing/2014/main" id="{4FBC2107-65E3-47D6-B40E-B3770D9E14BA}"/>
-              </a:ext>
-            </a:extLst>
-          </p:cNvPr>
-          <p:cNvSpPr>
-            <a:spLocks xmlns:a="http://schemas.openxmlformats.org/drawingml/2006/main" noGrp="1"/>
-          </p:cNvSpPr>
-          <p:nvPr/>
-        </p:nvSpPr>
-        <p:spPr>
-          <a:xfrm xmlns:a="http://schemas.openxmlformats.org/drawingml/2006/main">
-            <a:off x="1559052" y="4498848"/>
-            <a:ext cx="475488" cy="475488"/>
-          </a:xfrm>
-          <a:prstGeom xmlns:a="http://schemas.openxmlformats.org/drawingml/2006/main" prst="ellipse">
-            <a:avLst/>
-          </a:prstGeom>
-          <a:solidFill xmlns:a="http://schemas.openxmlformats.org/drawingml/2006/main">
-            <a:srgbClr val="FFFFFF"/>
-          </a:solidFill>
-        </p:spPr>
-      </p:sp>
-      <p:pic>
-        <p:nvPicPr>
-          <p:cNvPr id="74" name="Image 5"/>
-          <p:cNvPicPr>
-            <a:picLocks xmlns:a="http://schemas.openxmlformats.org/drawingml/2006/main" noChangeAspect="1"/>
-          </p:cNvPicPr>
-          <p:nvPr/>
-        </p:nvPicPr>
-        <p:blipFill>
-          <a:blip xmlns:r="http://schemas.openxmlformats.org/officeDocument/2006/relationships" xmlns:a="http://schemas.openxmlformats.org/drawingml/2006/main" r:embed="Rf07e9f72e881483a"/>
-          <a:stretch xmlns:a="http://schemas.openxmlformats.org/drawingml/2006/main">
-            <a:fillRect l="0" t="0" r="0" b="0"/>
-          </a:stretch>
-        </p:blipFill>
-        <p:spPr>
-          <a:xfrm xmlns:a="http://schemas.openxmlformats.org/drawingml/2006/main">
-            <a:off x="1668780" y="4608576"/>
-            <a:ext cx="256032" cy="256032"/>
-          </a:xfrm>
-          <a:prstGeom xmlns:a="http://schemas.openxmlformats.org/drawingml/2006/main" prst="rect">
-            <a:avLst/>
-          </a:prstGeom>
-        </p:spPr>
-      </p:pic>
-      <p:sp>
-        <p:nvSpPr>
-          <p:cNvPr id="25" name="Text 17">
-            <a:extLst xmlns:a="http://schemas.openxmlformats.org/drawingml/2006/main">
-              <a:ext uri="{FF2B5EF4-FFF2-40B4-BE49-F238E27FC236}">
-                <a16:creationId xmlns:a16="http://schemas.microsoft.com/office/drawing/2014/main" id="{F8734886-C74A-46F0-89E1-3FF3E4FE45E0}"/>
-              </a:ext>
-            </a:extLst>
-          </p:cNvPr>
-          <p:cNvSpPr>
-            <a:spLocks xmlns:a="http://schemas.openxmlformats.org/drawingml/2006/main" noGrp="1"/>
-          </p:cNvSpPr>
-          <p:nvPr/>
-        </p:nvSpPr>
-        <p:spPr>
-          <a:xfrm xmlns:a="http://schemas.openxmlformats.org/drawingml/2006/main">
-            <a:off x="612648" y="5047488"/>
-            <a:ext cx="2368296" cy="274320"/>
-          </a:xfrm>
-          <a:prstGeom xmlns:a="http://schemas.openxmlformats.org/drawingml/2006/main" prst="rect">
-            <a:avLst/>
-          </a:prstGeom>
-          <a:noFill xmlns:a="http://schemas.openxmlformats.org/drawingml/2006/main"/>
-        </p:spPr>
-        <p:txBody>
-          <a:bodyPr xmlns:a="http://schemas.openxmlformats.org/drawingml/2006/main" wrap="square" lIns="0" tIns="0" rIns="0" bIns="0" anchor="ctr"/>
-          <a:lstStyle xmlns:a="http://schemas.openxmlformats.org/drawingml/2006/main"/>
-          <a:p xmlns:a="http://schemas.openxmlformats.org/drawingml/2006/main">
-            <a:pPr marL="0" indent="0" algn="ctr">
-              <a:buNone/>
-            </a:pPr>
-            <a:r>
-              <a:rPr sz="1400" b="1">
-                <a:solidFill>
-                  <a:srgbClr val="1A1A1A"/>
-                </a:solidFill>
-                <a:latin typeface="Arial"/>
-                <a:ea typeface="Arial"/>
-                <a:cs typeface="Arial"/>
-              </a:rPr>
-              <a:t>File readers</a:t>
-            </a:r>
-            <a:endParaRPr sz="1400"/>
-          </a:p>
-        </p:txBody>
-      </p:sp>
-      <p:sp>
-        <p:nvSpPr>
-          <p:cNvPr id="26" name="Text 18">
-            <a:extLst xmlns:a="http://schemas.openxmlformats.org/drawingml/2006/main">
-              <a:ext uri="{FF2B5EF4-FFF2-40B4-BE49-F238E27FC236}">
-                <a16:creationId xmlns:a16="http://schemas.microsoft.com/office/drawing/2014/main" id="{88F5BE64-0190-4A75-9E79-270E7DDB73F5}"/>
-              </a:ext>
-            </a:extLst>
-          </p:cNvPr>
-          <p:cNvSpPr>
-            <a:spLocks xmlns:a="http://schemas.openxmlformats.org/drawingml/2006/main" noGrp="1"/>
-          </p:cNvSpPr>
-          <p:nvPr/>
-        </p:nvSpPr>
-        <p:spPr>
-          <a:xfrm xmlns:a="http://schemas.openxmlformats.org/drawingml/2006/main">
-            <a:off x="667512" y="5321808"/>
-            <a:ext cx="2258568" cy="594360"/>
+          <p:cNvPr id="74" name="Text 18"/>
+          <p:cNvSpPr>
+            <a:spLocks xmlns:a="http://schemas.openxmlformats.org/drawingml/2006/main" noGrp="1"/>
+          </p:cNvSpPr>
+          <p:nvPr/>
+        </p:nvSpPr>
+        <p:spPr>
+          <a:xfrm xmlns:a="http://schemas.openxmlformats.org/drawingml/2006/main">
+            <a:off x="594360" y="5486400"/>
+            <a:ext cx="1907438" cy="594360"/>
           </a:xfrm>
           <a:prstGeom xmlns:a="http://schemas.openxmlformats.org/drawingml/2006/main" prst="rect">
             <a:avLst/>
@@ -2180,7 +2173,7 @@
                 <a:spcPts val="0"/>
               </a:spcAft>
               <a:buNone/>
-              <a:defRPr sz="1100">
+              <a:defRPr sz="1000">
                 <a:solidFill>
                   <a:srgbClr val="666666"/>
                 </a:solidFill>
@@ -2190,7 +2183,7 @@
               </a:defRPr>
             </a:pPr>
             <a:r>
-              <a:rPr sz="1100">
+              <a:rPr sz="1000">
                 <a:solidFill>
                   <a:srgbClr val="666666"/>
                 </a:solidFill>
@@ -2210,7 +2203,7 @@
                 <a:spcPts val="0"/>
               </a:spcAft>
               <a:buNone/>
-              <a:defRPr sz="1100">
+              <a:defRPr sz="1000">
                 <a:solidFill>
                   <a:srgbClr val="666666"/>
                 </a:solidFill>
@@ -2220,7 +2213,7 @@
               </a:defRPr>
             </a:pPr>
             <a:r>
-              <a:rPr sz="1100">
+              <a:rPr sz="1000">
                 <a:solidFill>
                   <a:srgbClr val="666666"/>
                 </a:solidFill>
@@ -2228,29 +2221,23 @@
                 <a:ea typeface="Arial"/>
                 <a:cs typeface="Arial"/>
               </a:rPr>
-              <a:t>MGF · MS2 · MSP · MS1/MS2</a:t>
+              <a:t>MGF · MS2 · MSP · mzSpecLib</a:t>
             </a:r>
           </a:p>
         </p:txBody>
       </p:sp>
       <p:sp>
         <p:nvSpPr>
-          <p:cNvPr id="27" name="Shape 19">
-            <a:extLst xmlns:a="http://schemas.openxmlformats.org/drawingml/2006/main">
-              <a:ext uri="{FF2B5EF4-FFF2-40B4-BE49-F238E27FC236}">
-                <a16:creationId xmlns:a16="http://schemas.microsoft.com/office/drawing/2014/main" id="{DEFDD63B-564C-4A58-9759-E6571465679D}"/>
-              </a:ext>
-            </a:extLst>
-          </p:cNvPr>
-          <p:cNvSpPr>
-            <a:spLocks xmlns:a="http://schemas.openxmlformats.org/drawingml/2006/main" noGrp="1"/>
-          </p:cNvSpPr>
-          <p:nvPr/>
-        </p:nvSpPr>
-        <p:spPr>
-          <a:xfrm xmlns:a="http://schemas.openxmlformats.org/drawingml/2006/main">
-            <a:off x="3364992" y="4315968"/>
-            <a:ext cx="2587752" cy="1691640"/>
+          <p:cNvPr id="75" name="Shape 15"/>
+          <p:cNvSpPr>
+            <a:spLocks xmlns:a="http://schemas.openxmlformats.org/drawingml/2006/main" noGrp="1"/>
+          </p:cNvSpPr>
+          <p:nvPr/>
+        </p:nvSpPr>
+        <p:spPr>
+          <a:xfrm xmlns:a="http://schemas.openxmlformats.org/drawingml/2006/main">
+            <a:off x="2776118" y="4480560"/>
+            <a:ext cx="2090318" cy="1691640"/>
           </a:xfrm>
           <a:prstGeom xmlns:a="http://schemas.openxmlformats.org/drawingml/2006/main" prst="roundRect">
             <a:avLst>
@@ -2264,21 +2251,15 @@
       </p:sp>
       <p:sp>
         <p:nvSpPr>
-          <p:cNvPr id="28" name="Shape 20">
-            <a:extLst xmlns:a="http://schemas.openxmlformats.org/drawingml/2006/main">
-              <a:ext uri="{FF2B5EF4-FFF2-40B4-BE49-F238E27FC236}">
-                <a16:creationId xmlns:a16="http://schemas.microsoft.com/office/drawing/2014/main" id="{ED07956C-F001-42FF-A157-64C71420F2B0}"/>
-              </a:ext>
-            </a:extLst>
-          </p:cNvPr>
-          <p:cNvSpPr>
-            <a:spLocks xmlns:a="http://schemas.openxmlformats.org/drawingml/2006/main" noGrp="1"/>
-          </p:cNvSpPr>
-          <p:nvPr/>
-        </p:nvSpPr>
-        <p:spPr>
-          <a:xfrm xmlns:a="http://schemas.openxmlformats.org/drawingml/2006/main">
-            <a:off x="4421124" y="4498848"/>
+          <p:cNvPr id="76" name="Shape 16"/>
+          <p:cNvSpPr>
+            <a:spLocks xmlns:a="http://schemas.openxmlformats.org/drawingml/2006/main" noGrp="1"/>
+          </p:cNvSpPr>
+          <p:nvPr/>
+        </p:nvSpPr>
+        <p:spPr>
+          <a:xfrm xmlns:a="http://schemas.openxmlformats.org/drawingml/2006/main">
+            <a:off x="3583533" y="4663440"/>
             <a:ext cx="475488" cy="475488"/>
           </a:xfrm>
           <a:prstGeom xmlns:a="http://schemas.openxmlformats.org/drawingml/2006/main" prst="ellipse">
@@ -2291,7 +2272,7 @@
       </p:sp>
       <p:pic>
         <p:nvPicPr>
-          <p:cNvPr id="79" name="Image 6"/>
+          <p:cNvPr id="77" name="Image 5"/>
           <p:cNvPicPr>
             <a:picLocks xmlns:a="http://schemas.openxmlformats.org/drawingml/2006/main" noChangeAspect="1"/>
           </p:cNvPicPr>
@@ -2305,7 +2286,7 @@
         </p:blipFill>
         <p:spPr>
           <a:xfrm xmlns:a="http://schemas.openxmlformats.org/drawingml/2006/main">
-            <a:off x="4530852" y="4608576"/>
+            <a:off x="3693261" y="4773168"/>
             <a:ext cx="256032" cy="256032"/>
           </a:xfrm>
           <a:prstGeom xmlns:a="http://schemas.openxmlformats.org/drawingml/2006/main" prst="rect">
@@ -2315,22 +2296,16 @@
       </p:pic>
       <p:sp>
         <p:nvSpPr>
-          <p:cNvPr id="30" name="Text 21">
-            <a:extLst xmlns:a="http://schemas.openxmlformats.org/drawingml/2006/main">
-              <a:ext uri="{FF2B5EF4-FFF2-40B4-BE49-F238E27FC236}">
-                <a16:creationId xmlns:a16="http://schemas.microsoft.com/office/drawing/2014/main" id="{673AC3B8-5DAD-42D4-8B7F-FD7308DF54C6}"/>
-              </a:ext>
-            </a:extLst>
-          </p:cNvPr>
-          <p:cNvSpPr>
-            <a:spLocks xmlns:a="http://schemas.openxmlformats.org/drawingml/2006/main" noGrp="1"/>
-          </p:cNvSpPr>
-          <p:nvPr/>
-        </p:nvSpPr>
-        <p:spPr>
-          <a:xfrm xmlns:a="http://schemas.openxmlformats.org/drawingml/2006/main">
-            <a:off x="3474720" y="5047488"/>
-            <a:ext cx="2368296" cy="274320"/>
+          <p:cNvPr id="78" name="Text 17"/>
+          <p:cNvSpPr>
+            <a:spLocks xmlns:a="http://schemas.openxmlformats.org/drawingml/2006/main" noGrp="1"/>
+          </p:cNvSpPr>
+          <p:nvPr/>
+        </p:nvSpPr>
+        <p:spPr>
+          <a:xfrm xmlns:a="http://schemas.openxmlformats.org/drawingml/2006/main">
+            <a:off x="2830982" y="5212080"/>
+            <a:ext cx="1980590" cy="274320"/>
           </a:xfrm>
           <a:prstGeom xmlns:a="http://schemas.openxmlformats.org/drawingml/2006/main" prst="rect">
             <a:avLst/>
@@ -2345,7 +2320,7 @@
               <a:buNone/>
             </a:pPr>
             <a:r>
-              <a:rPr sz="1400" b="1">
+              <a:rPr sz="1300" b="1">
                 <a:solidFill>
                   <a:srgbClr val="1A1A1A"/>
                 </a:solidFill>
@@ -2355,28 +2330,22 @@
               </a:rPr>
               <a:t>Fast deconvolution</a:t>
             </a:r>
-            <a:endParaRPr sz="1400"/>
+            <a:endParaRPr sz="1300"/>
           </a:p>
         </p:txBody>
       </p:sp>
       <p:sp>
         <p:nvSpPr>
-          <p:cNvPr id="31" name="Text 22">
-            <a:extLst xmlns:a="http://schemas.openxmlformats.org/drawingml/2006/main">
-              <a:ext uri="{FF2B5EF4-FFF2-40B4-BE49-F238E27FC236}">
-                <a16:creationId xmlns:a16="http://schemas.microsoft.com/office/drawing/2014/main" id="{28250044-5CDB-44B6-82D3-BBDE11526004}"/>
-              </a:ext>
-            </a:extLst>
-          </p:cNvPr>
-          <p:cNvSpPr>
-            <a:spLocks xmlns:a="http://schemas.openxmlformats.org/drawingml/2006/main" noGrp="1"/>
-          </p:cNvSpPr>
-          <p:nvPr/>
-        </p:nvSpPr>
-        <p:spPr>
-          <a:xfrm xmlns:a="http://schemas.openxmlformats.org/drawingml/2006/main">
-            <a:off x="3529584" y="5321808"/>
-            <a:ext cx="2258568" cy="594360"/>
+          <p:cNvPr id="79" name="Text 18"/>
+          <p:cNvSpPr>
+            <a:spLocks xmlns:a="http://schemas.openxmlformats.org/drawingml/2006/main" noGrp="1"/>
+          </p:cNvSpPr>
+          <p:nvPr/>
+        </p:nvSpPr>
+        <p:spPr>
+          <a:xfrm xmlns:a="http://schemas.openxmlformats.org/drawingml/2006/main">
+            <a:off x="2867558" y="5486400"/>
+            <a:ext cx="1907438" cy="594360"/>
           </a:xfrm>
           <a:prstGeom xmlns:a="http://schemas.openxmlformats.org/drawingml/2006/main" prst="rect">
             <a:avLst/>
@@ -2397,7 +2366,7 @@
                 <a:spcPts val="0"/>
               </a:spcAft>
               <a:buNone/>
-              <a:defRPr sz="1100">
+              <a:defRPr sz="1000">
                 <a:solidFill>
                   <a:srgbClr val="666666"/>
                 </a:solidFill>
@@ -2407,7 +2376,7 @@
               </a:defRPr>
             </a:pPr>
             <a:r>
-              <a:rPr sz="1100">
+              <a:rPr sz="1000">
                 <a:solidFill>
                   <a:srgbClr val="666666"/>
                 </a:solidFill>
@@ -2415,7 +2384,7 @@
                 <a:ea typeface="Arial"/>
                 <a:cs typeface="Arial"/>
               </a:rPr>
-              <a:t>Greedy isotope cluster scoring</a:t>
+              <a:t>Greedy isotope-cluster scoring</a:t>
             </a:r>
           </a:p>
           <a:p xmlns:a="http://schemas.openxmlformats.org/drawingml/2006/main">
@@ -2427,7 +2396,7 @@
                 <a:spcPts val="0"/>
               </a:spcAft>
               <a:buNone/>
-              <a:defRPr sz="1100">
+              <a:defRPr sz="1000">
                 <a:solidFill>
                   <a:srgbClr val="666666"/>
                 </a:solidFill>
@@ -2437,7 +2406,7 @@
               </a:defRPr>
             </a:pPr>
             <a:r>
-              <a:rPr sz="1100">
+              <a:rPr sz="1000">
                 <a:solidFill>
                   <a:srgbClr val="666666"/>
                 </a:solidFill>
@@ -2445,29 +2414,23 @@
                 <a:ea typeface="Arial"/>
                 <a:cs typeface="Arial"/>
               </a:rPr>
-              <a:t>Numba JIT accelerated scoring</a:t>
+              <a:t>Numba JIT acceleration</a:t>
             </a:r>
           </a:p>
         </p:txBody>
       </p:sp>
       <p:sp>
         <p:nvSpPr>
-          <p:cNvPr id="32" name="Shape 23">
-            <a:extLst xmlns:a="http://schemas.openxmlformats.org/drawingml/2006/main">
-              <a:ext uri="{FF2B5EF4-FFF2-40B4-BE49-F238E27FC236}">
-                <a16:creationId xmlns:a16="http://schemas.microsoft.com/office/drawing/2014/main" id="{D857791A-571B-48D1-AE7B-9DCE447DF04F}"/>
-              </a:ext>
-            </a:extLst>
-          </p:cNvPr>
-          <p:cNvSpPr>
-            <a:spLocks xmlns:a="http://schemas.openxmlformats.org/drawingml/2006/main" noGrp="1"/>
-          </p:cNvSpPr>
-          <p:nvPr/>
-        </p:nvSpPr>
-        <p:spPr>
-          <a:xfrm xmlns:a="http://schemas.openxmlformats.org/drawingml/2006/main">
-            <a:off x="6227064" y="4315968"/>
-            <a:ext cx="2587752" cy="1691640"/>
+          <p:cNvPr id="80" name="Shape 15"/>
+          <p:cNvSpPr>
+            <a:spLocks xmlns:a="http://schemas.openxmlformats.org/drawingml/2006/main" noGrp="1"/>
+          </p:cNvSpPr>
+          <p:nvPr/>
+        </p:nvSpPr>
+        <p:spPr>
+          <a:xfrm xmlns:a="http://schemas.openxmlformats.org/drawingml/2006/main">
+            <a:off x="5049316" y="4480560"/>
+            <a:ext cx="2090318" cy="1691640"/>
           </a:xfrm>
           <a:prstGeom xmlns:a="http://schemas.openxmlformats.org/drawingml/2006/main" prst="roundRect">
             <a:avLst>
@@ -2481,21 +2444,15 @@
       </p:sp>
       <p:sp>
         <p:nvSpPr>
-          <p:cNvPr id="33" name="Shape 24">
-            <a:extLst xmlns:a="http://schemas.openxmlformats.org/drawingml/2006/main">
-              <a:ext uri="{FF2B5EF4-FFF2-40B4-BE49-F238E27FC236}">
-                <a16:creationId xmlns:a16="http://schemas.microsoft.com/office/drawing/2014/main" id="{08F74029-4262-4F68-A8C4-E3BC19BE5B7D}"/>
-              </a:ext>
-            </a:extLst>
-          </p:cNvPr>
-          <p:cNvSpPr>
-            <a:spLocks xmlns:a="http://schemas.openxmlformats.org/drawingml/2006/main" noGrp="1"/>
-          </p:cNvSpPr>
-          <p:nvPr/>
-        </p:nvSpPr>
-        <p:spPr>
-          <a:xfrm xmlns:a="http://schemas.openxmlformats.org/drawingml/2006/main">
-            <a:off x="7283196" y="4498848"/>
+          <p:cNvPr id="81" name="Shape 16"/>
+          <p:cNvSpPr>
+            <a:spLocks xmlns:a="http://schemas.openxmlformats.org/drawingml/2006/main" noGrp="1"/>
+          </p:cNvSpPr>
+          <p:nvPr/>
+        </p:nvSpPr>
+        <p:spPr>
+          <a:xfrm xmlns:a="http://schemas.openxmlformats.org/drawingml/2006/main">
+            <a:off x="5856731" y="4663440"/>
             <a:ext cx="475488" cy="475488"/>
           </a:xfrm>
           <a:prstGeom xmlns:a="http://schemas.openxmlformats.org/drawingml/2006/main" prst="ellipse">
@@ -2508,21 +2465,21 @@
       </p:sp>
       <p:pic>
         <p:nvPicPr>
-          <p:cNvPr id="84" name="Image 7"/>
+          <p:cNvPr id="82" name="Image 5"/>
           <p:cNvPicPr>
             <a:picLocks xmlns:a="http://schemas.openxmlformats.org/drawingml/2006/main" noChangeAspect="1"/>
           </p:cNvPicPr>
           <p:nvPr/>
         </p:nvPicPr>
         <p:blipFill>
-          <a:blip xmlns:r="http://schemas.openxmlformats.org/officeDocument/2006/relationships" xmlns:a="http://schemas.openxmlformats.org/drawingml/2006/main" r:embed="R549a3dbc291142b2"/>
+          <a:blip xmlns:r="http://schemas.openxmlformats.org/officeDocument/2006/relationships" xmlns:a="http://schemas.openxmlformats.org/drawingml/2006/main" r:embed="rId12"/>
           <a:stretch xmlns:a="http://schemas.openxmlformats.org/drawingml/2006/main">
             <a:fillRect l="0" t="0" r="0" b="0"/>
           </a:stretch>
         </p:blipFill>
         <p:spPr>
           <a:xfrm xmlns:a="http://schemas.openxmlformats.org/drawingml/2006/main">
-            <a:off x="7392924" y="4608576"/>
+            <a:off x="5966459" y="4773168"/>
             <a:ext cx="256032" cy="256032"/>
           </a:xfrm>
           <a:prstGeom xmlns:a="http://schemas.openxmlformats.org/drawingml/2006/main" prst="rect">
@@ -2532,22 +2489,16 @@
       </p:pic>
       <p:sp>
         <p:nvSpPr>
-          <p:cNvPr id="35" name="Text 25">
-            <a:extLst xmlns:a="http://schemas.openxmlformats.org/drawingml/2006/main">
-              <a:ext uri="{FF2B5EF4-FFF2-40B4-BE49-F238E27FC236}">
-                <a16:creationId xmlns:a16="http://schemas.microsoft.com/office/drawing/2014/main" id="{75BEEEE4-A85F-449E-AD63-8AF80A1130DE}"/>
-              </a:ext>
-            </a:extLst>
-          </p:cNvPr>
-          <p:cNvSpPr>
-            <a:spLocks xmlns:a="http://schemas.openxmlformats.org/drawingml/2006/main" noGrp="1"/>
-          </p:cNvSpPr>
-          <p:nvPr/>
-        </p:nvSpPr>
-        <p:spPr>
-          <a:xfrm xmlns:a="http://schemas.openxmlformats.org/drawingml/2006/main">
-            <a:off x="6336792" y="5047488"/>
-            <a:ext cx="2368296" cy="274320"/>
+          <p:cNvPr id="83" name="Text 17"/>
+          <p:cNvSpPr>
+            <a:spLocks xmlns:a="http://schemas.openxmlformats.org/drawingml/2006/main" noGrp="1"/>
+          </p:cNvSpPr>
+          <p:nvPr/>
+        </p:nvSpPr>
+        <p:spPr>
+          <a:xfrm xmlns:a="http://schemas.openxmlformats.org/drawingml/2006/main">
+            <a:off x="5104180" y="5212080"/>
+            <a:ext cx="1980590" cy="274320"/>
           </a:xfrm>
           <a:prstGeom xmlns:a="http://schemas.openxmlformats.org/drawingml/2006/main" prst="rect">
             <a:avLst/>
@@ -2562,7 +2513,7 @@
               <a:buNone/>
             </a:pPr>
             <a:r>
-              <a:rPr sz="1400" b="1">
+              <a:rPr sz="1300" b="1">
                 <a:solidFill>
                   <a:srgbClr val="1A1A1A"/>
                 </a:solidFill>
@@ -2570,30 +2521,24 @@
                 <a:ea typeface="Arial"/>
                 <a:cs typeface="Arial"/>
               </a:rPr>
-              <a:t>Ecosystem adapters</a:t>
-            </a:r>
-            <a:endParaRPr sz="1400"/>
+              <a:t>Publication figures</a:t>
+            </a:r>
+            <a:endParaRPr sz="1300"/>
           </a:p>
         </p:txBody>
       </p:sp>
       <p:sp>
         <p:nvSpPr>
-          <p:cNvPr id="36" name="Text 26">
-            <a:extLst xmlns:a="http://schemas.openxmlformats.org/drawingml/2006/main">
-              <a:ext uri="{FF2B5EF4-FFF2-40B4-BE49-F238E27FC236}">
-                <a16:creationId xmlns:a16="http://schemas.microsoft.com/office/drawing/2014/main" id="{F74A86CA-F9DE-4E08-A36C-356548127107}"/>
-              </a:ext>
-            </a:extLst>
-          </p:cNvPr>
-          <p:cNvSpPr>
-            <a:spLocks xmlns:a="http://schemas.openxmlformats.org/drawingml/2006/main" noGrp="1"/>
-          </p:cNvSpPr>
-          <p:nvPr/>
-        </p:nvSpPr>
-        <p:spPr>
-          <a:xfrm xmlns:a="http://schemas.openxmlformats.org/drawingml/2006/main">
-            <a:off x="6391656" y="5321808"/>
-            <a:ext cx="2258568" cy="594360"/>
+          <p:cNvPr id="84" name="Text 18"/>
+          <p:cNvSpPr>
+            <a:spLocks xmlns:a="http://schemas.openxmlformats.org/drawingml/2006/main" noGrp="1"/>
+          </p:cNvSpPr>
+          <p:nvPr/>
+        </p:nvSpPr>
+        <p:spPr>
+          <a:xfrm xmlns:a="http://schemas.openxmlformats.org/drawingml/2006/main">
+            <a:off x="5140756" y="5486400"/>
+            <a:ext cx="1907438" cy="594360"/>
           </a:xfrm>
           <a:prstGeom xmlns:a="http://schemas.openxmlformats.org/drawingml/2006/main" prst="rect">
             <a:avLst/>
@@ -2614,7 +2559,7 @@
                 <a:spcPts val="0"/>
               </a:spcAft>
               <a:buNone/>
-              <a:defRPr sz="1100">
+              <a:defRPr sz="1000">
                 <a:solidFill>
                   <a:srgbClr val="666666"/>
                 </a:solidFill>
@@ -2624,7 +2569,7 @@
               </a:defRPr>
             </a:pPr>
             <a:r>
-              <a:rPr sz="1100">
+              <a:rPr sz="1000">
                 <a:solidFill>
                   <a:srgbClr val="666666"/>
                 </a:solidFill>
@@ -2632,7 +2577,7 @@
                 <a:ea typeface="Arial"/>
                 <a:cs typeface="Arial"/>
               </a:rPr>
-              <a:t>matchms + spectrum_utils adapters</a:t>
+              <a:t>plotly or matplotlib backends</a:t>
             </a:r>
           </a:p>
           <a:p xmlns:a="http://schemas.openxmlformats.org/drawingml/2006/main">
@@ -2644,7 +2589,7 @@
                 <a:spcPts val="0"/>
               </a:spcAft>
               <a:buNone/>
-              <a:defRPr sz="1100">
+              <a:defRPr sz="1000">
                 <a:solidFill>
                   <a:srgbClr val="666666"/>
                 </a:solidFill>
@@ -2654,7 +2599,7 @@
               </a:defRPr>
             </a:pPr>
             <a:r>
-              <a:rPr sz="1100">
+              <a:rPr sz="1000">
                 <a:solidFill>
                   <a:srgbClr val="666666"/>
                 </a:solidFill>
@@ -2662,29 +2607,23 @@
                 <a:ea typeface="Arial"/>
                 <a:cs typeface="Arial"/>
               </a:rPr>
-              <a:t>Bidirectional ecosystem conversion</a:t>
+              <a:t>Journal sizes · PDF/SVG export</a:t>
             </a:r>
           </a:p>
         </p:txBody>
       </p:sp>
       <p:sp>
         <p:nvSpPr>
-          <p:cNvPr id="37" name="Shape 27">
-            <a:extLst xmlns:a="http://schemas.openxmlformats.org/drawingml/2006/main">
-              <a:ext uri="{FF2B5EF4-FFF2-40B4-BE49-F238E27FC236}">
-                <a16:creationId xmlns:a16="http://schemas.microsoft.com/office/drawing/2014/main" id="{D6DB1CD5-F6F0-4A85-BF94-73131BF3C80A}"/>
-              </a:ext>
-            </a:extLst>
-          </p:cNvPr>
-          <p:cNvSpPr>
-            <a:spLocks xmlns:a="http://schemas.openxmlformats.org/drawingml/2006/main" noGrp="1"/>
-          </p:cNvSpPr>
-          <p:nvPr/>
-        </p:nvSpPr>
-        <p:spPr>
-          <a:xfrm xmlns:a="http://schemas.openxmlformats.org/drawingml/2006/main">
-            <a:off x="9089136" y="4315968"/>
-            <a:ext cx="2587752" cy="1691640"/>
+          <p:cNvPr id="85" name="Shape 15"/>
+          <p:cNvSpPr>
+            <a:spLocks xmlns:a="http://schemas.openxmlformats.org/drawingml/2006/main" noGrp="1"/>
+          </p:cNvSpPr>
+          <p:nvPr/>
+        </p:nvSpPr>
+        <p:spPr>
+          <a:xfrm xmlns:a="http://schemas.openxmlformats.org/drawingml/2006/main">
+            <a:off x="7322514" y="4480560"/>
+            <a:ext cx="2090318" cy="1691640"/>
           </a:xfrm>
           <a:prstGeom xmlns:a="http://schemas.openxmlformats.org/drawingml/2006/main" prst="roundRect">
             <a:avLst>
@@ -2698,21 +2637,15 @@
       </p:sp>
       <p:sp>
         <p:nvSpPr>
-          <p:cNvPr id="38" name="Shape 28">
-            <a:extLst xmlns:a="http://schemas.openxmlformats.org/drawingml/2006/main">
-              <a:ext uri="{FF2B5EF4-FFF2-40B4-BE49-F238E27FC236}">
-                <a16:creationId xmlns:a16="http://schemas.microsoft.com/office/drawing/2014/main" id="{ED357E3B-3F18-44A7-A77B-42DC115B64DC}"/>
-              </a:ext>
-            </a:extLst>
-          </p:cNvPr>
-          <p:cNvSpPr>
-            <a:spLocks xmlns:a="http://schemas.openxmlformats.org/drawingml/2006/main" noGrp="1"/>
-          </p:cNvSpPr>
-          <p:nvPr/>
-        </p:nvSpPr>
-        <p:spPr>
-          <a:xfrm xmlns:a="http://schemas.openxmlformats.org/drawingml/2006/main">
-            <a:off x="10145268" y="4498848"/>
+          <p:cNvPr id="86" name="Shape 16"/>
+          <p:cNvSpPr>
+            <a:spLocks xmlns:a="http://schemas.openxmlformats.org/drawingml/2006/main" noGrp="1"/>
+          </p:cNvSpPr>
+          <p:nvPr/>
+        </p:nvSpPr>
+        <p:spPr>
+          <a:xfrm xmlns:a="http://schemas.openxmlformats.org/drawingml/2006/main">
+            <a:off x="8129929" y="4663440"/>
             <a:ext cx="475488" cy="475488"/>
           </a:xfrm>
           <a:prstGeom xmlns:a="http://schemas.openxmlformats.org/drawingml/2006/main" prst="ellipse">
@@ -2725,21 +2658,21 @@
       </p:sp>
       <p:pic>
         <p:nvPicPr>
-          <p:cNvPr id="89" name="Image 8"/>
+          <p:cNvPr id="87" name="Image 5"/>
           <p:cNvPicPr>
             <a:picLocks xmlns:a="http://schemas.openxmlformats.org/drawingml/2006/main" noChangeAspect="1"/>
           </p:cNvPicPr>
           <p:nvPr/>
         </p:nvPicPr>
         <p:blipFill>
-          <a:blip xmlns:r="http://schemas.openxmlformats.org/officeDocument/2006/relationships" xmlns:a="http://schemas.openxmlformats.org/drawingml/2006/main" r:embed="R34b6f29f1d7d499f"/>
+          <a:blip xmlns:r="http://schemas.openxmlformats.org/officeDocument/2006/relationships" xmlns:a="http://schemas.openxmlformats.org/drawingml/2006/main" r:embed="rId13"/>
           <a:stretch xmlns:a="http://schemas.openxmlformats.org/drawingml/2006/main">
             <a:fillRect l="0" t="0" r="0" b="0"/>
           </a:stretch>
         </p:blipFill>
         <p:spPr>
           <a:xfrm xmlns:a="http://schemas.openxmlformats.org/drawingml/2006/main">
-            <a:off x="10254996" y="4608576"/>
+            <a:off x="8239657" y="4773168"/>
             <a:ext cx="256032" cy="256032"/>
           </a:xfrm>
           <a:prstGeom xmlns:a="http://schemas.openxmlformats.org/drawingml/2006/main" prst="rect">
@@ -2749,22 +2682,16 @@
       </p:pic>
       <p:sp>
         <p:nvSpPr>
-          <p:cNvPr id="40" name="Text 29">
-            <a:extLst xmlns:a="http://schemas.openxmlformats.org/drawingml/2006/main">
-              <a:ext uri="{FF2B5EF4-FFF2-40B4-BE49-F238E27FC236}">
-                <a16:creationId xmlns:a16="http://schemas.microsoft.com/office/drawing/2014/main" id="{868D93F8-3217-4415-A8DD-B608EB610302}"/>
-              </a:ext>
-            </a:extLst>
-          </p:cNvPr>
-          <p:cNvSpPr>
-            <a:spLocks xmlns:a="http://schemas.openxmlformats.org/drawingml/2006/main" noGrp="1"/>
-          </p:cNvSpPr>
-          <p:nvPr/>
-        </p:nvSpPr>
-        <p:spPr>
-          <a:xfrm xmlns:a="http://schemas.openxmlformats.org/drawingml/2006/main">
-            <a:off x="9198864" y="5047488"/>
-            <a:ext cx="2368296" cy="274320"/>
+          <p:cNvPr id="88" name="Text 17"/>
+          <p:cNvSpPr>
+            <a:spLocks xmlns:a="http://schemas.openxmlformats.org/drawingml/2006/main" noGrp="1"/>
+          </p:cNvSpPr>
+          <p:nvPr/>
+        </p:nvSpPr>
+        <p:spPr>
+          <a:xfrm xmlns:a="http://schemas.openxmlformats.org/drawingml/2006/main">
+            <a:off x="7377378" y="5212080"/>
+            <a:ext cx="1980590" cy="274320"/>
           </a:xfrm>
           <a:prstGeom xmlns:a="http://schemas.openxmlformats.org/drawingml/2006/main" prst="rect">
             <a:avLst/>
@@ -2779,7 +2706,7 @@
               <a:buNone/>
             </a:pPr>
             <a:r>
-              <a:rPr sz="1400" b="1">
+              <a:rPr sz="1300" b="1">
                 <a:solidFill>
                   <a:srgbClr val="1A1A1A"/>
                 </a:solidFill>
@@ -2787,30 +2714,24 @@
                 <a:ea typeface="Arial"/>
                 <a:cs typeface="Arial"/>
               </a:rPr>
-              <a:t>Spectrum sharing</a:t>
-            </a:r>
-            <a:endParaRPr sz="1400"/>
+              <a:t>Reporter ions</a:t>
+            </a:r>
+            <a:endParaRPr sz="1300"/>
           </a:p>
         </p:txBody>
       </p:sp>
       <p:sp>
         <p:nvSpPr>
-          <p:cNvPr id="41" name="Text 30">
-            <a:extLst xmlns:a="http://schemas.openxmlformats.org/drawingml/2006/main">
-              <a:ext uri="{FF2B5EF4-FFF2-40B4-BE49-F238E27FC236}">
-                <a16:creationId xmlns:a16="http://schemas.microsoft.com/office/drawing/2014/main" id="{3E870868-DBFC-4122-95A4-CB45822072AB}"/>
-              </a:ext>
-            </a:extLst>
-          </p:cNvPr>
-          <p:cNvSpPr>
-            <a:spLocks xmlns:a="http://schemas.openxmlformats.org/drawingml/2006/main" noGrp="1"/>
-          </p:cNvSpPr>
-          <p:nvPr/>
-        </p:nvSpPr>
-        <p:spPr>
-          <a:xfrm xmlns:a="http://schemas.openxmlformats.org/drawingml/2006/main">
-            <a:off x="9253728" y="5321808"/>
-            <a:ext cx="2258568" cy="594360"/>
+          <p:cNvPr id="89" name="Text 18"/>
+          <p:cNvSpPr>
+            <a:spLocks xmlns:a="http://schemas.openxmlformats.org/drawingml/2006/main" noGrp="1"/>
+          </p:cNvSpPr>
+          <p:nvPr/>
+        </p:nvSpPr>
+        <p:spPr>
+          <a:xfrm xmlns:a="http://schemas.openxmlformats.org/drawingml/2006/main">
+            <a:off x="7413954" y="5486400"/>
+            <a:ext cx="1907438" cy="594360"/>
           </a:xfrm>
           <a:prstGeom xmlns:a="http://schemas.openxmlformats.org/drawingml/2006/main" prst="rect">
             <a:avLst/>
@@ -2831,7 +2752,7 @@
                 <a:spcPts val="0"/>
               </a:spcAft>
               <a:buNone/>
-              <a:defRPr sz="1100">
+              <a:defRPr sz="1000">
                 <a:solidFill>
                   <a:srgbClr val="666666"/>
                 </a:solidFill>
@@ -2841,7 +2762,7 @@
               </a:defRPr>
             </a:pPr>
             <a:r>
-              <a:rPr sz="1100">
+              <a:rPr sz="1000">
                 <a:solidFill>
                   <a:srgbClr val="666666"/>
                 </a:solidFill>
@@ -2849,7 +2770,7 @@
                 <a:ea typeface="Arial"/>
                 <a:cs typeface="Arial"/>
               </a:rPr>
-              <a:t>Compact URL-safe spectrl tokens</a:t>
+              <a:t>TMT · TMTpro · iTRAQ</a:t>
             </a:r>
           </a:p>
           <a:p xmlns:a="http://schemas.openxmlformats.org/drawingml/2006/main">
@@ -2861,7 +2782,7 @@
                 <a:spcPts val="0"/>
               </a:spcAft>
               <a:buNone/>
-              <a:defRPr sz="1100">
+              <a:defRPr sz="1000">
                 <a:solidFill>
                   <a:srgbClr val="666666"/>
                 </a:solidFill>
@@ -2871,7 +2792,7 @@
               </a:defRPr>
             </a:pPr>
             <a:r>
-              <a:rPr sz="1100">
+              <a:rPr sz="1000">
                 <a:solidFill>
                   <a:srgbClr val="666666"/>
                 </a:solidFill>
@@ -2879,7 +2800,200 @@
                 <a:ea typeface="Arial"/>
                 <a:cs typeface="Arial"/>
               </a:rPr>
-              <a:t>Backend-free sharing with spectrl</a:t>
+              <a:t>Impurity-corrected channels</a:t>
+            </a:r>
+          </a:p>
+        </p:txBody>
+      </p:sp>
+      <p:sp>
+        <p:nvSpPr>
+          <p:cNvPr id="90" name="Shape 15"/>
+          <p:cNvSpPr>
+            <a:spLocks xmlns:a="http://schemas.openxmlformats.org/drawingml/2006/main" noGrp="1"/>
+          </p:cNvSpPr>
+          <p:nvPr/>
+        </p:nvSpPr>
+        <p:spPr>
+          <a:xfrm xmlns:a="http://schemas.openxmlformats.org/drawingml/2006/main">
+            <a:off x="9595712" y="4480560"/>
+            <a:ext cx="2090318" cy="1691640"/>
+          </a:xfrm>
+          <a:prstGeom xmlns:a="http://schemas.openxmlformats.org/drawingml/2006/main" prst="roundRect">
+            <a:avLst>
+              <a:gd name="adj" fmla="val 4865"/>
+            </a:avLst>
+          </a:prstGeom>
+          <a:solidFill xmlns:a="http://schemas.openxmlformats.org/drawingml/2006/main">
+            <a:srgbClr val="F3F4F6"/>
+          </a:solidFill>
+        </p:spPr>
+      </p:sp>
+      <p:sp>
+        <p:nvSpPr>
+          <p:cNvPr id="91" name="Shape 16"/>
+          <p:cNvSpPr>
+            <a:spLocks xmlns:a="http://schemas.openxmlformats.org/drawingml/2006/main" noGrp="1"/>
+          </p:cNvSpPr>
+          <p:nvPr/>
+        </p:nvSpPr>
+        <p:spPr>
+          <a:xfrm xmlns:a="http://schemas.openxmlformats.org/drawingml/2006/main">
+            <a:off x="10403127" y="4663440"/>
+            <a:ext cx="475488" cy="475488"/>
+          </a:xfrm>
+          <a:prstGeom xmlns:a="http://schemas.openxmlformats.org/drawingml/2006/main" prst="ellipse">
+            <a:avLst/>
+          </a:prstGeom>
+          <a:solidFill xmlns:a="http://schemas.openxmlformats.org/drawingml/2006/main">
+            <a:srgbClr val="FFFFFF"/>
+          </a:solidFill>
+        </p:spPr>
+      </p:sp>
+      <p:pic>
+        <p:nvPicPr>
+          <p:cNvPr id="92" name="Image 5"/>
+          <p:cNvPicPr>
+            <a:picLocks xmlns:a="http://schemas.openxmlformats.org/drawingml/2006/main" noChangeAspect="1"/>
+          </p:cNvPicPr>
+          <p:nvPr/>
+        </p:nvPicPr>
+        <p:blipFill>
+          <a:blip xmlns:r="http://schemas.openxmlformats.org/officeDocument/2006/relationships" xmlns:a="http://schemas.openxmlformats.org/drawingml/2006/main" r:embed="rId14"/>
+          <a:stretch xmlns:a="http://schemas.openxmlformats.org/drawingml/2006/main">
+            <a:fillRect l="0" t="0" r="0" b="0"/>
+          </a:stretch>
+        </p:blipFill>
+        <p:spPr>
+          <a:xfrm xmlns:a="http://schemas.openxmlformats.org/drawingml/2006/main">
+            <a:off x="10512855" y="4773168"/>
+            <a:ext cx="256032" cy="256032"/>
+          </a:xfrm>
+          <a:prstGeom xmlns:a="http://schemas.openxmlformats.org/drawingml/2006/main" prst="rect">
+            <a:avLst/>
+          </a:prstGeom>
+        </p:spPr>
+      </p:pic>
+      <p:sp>
+        <p:nvSpPr>
+          <p:cNvPr id="93" name="Text 17"/>
+          <p:cNvSpPr>
+            <a:spLocks xmlns:a="http://schemas.openxmlformats.org/drawingml/2006/main" noGrp="1"/>
+          </p:cNvSpPr>
+          <p:nvPr/>
+        </p:nvSpPr>
+        <p:spPr>
+          <a:xfrm xmlns:a="http://schemas.openxmlformats.org/drawingml/2006/main">
+            <a:off x="9650576" y="5212080"/>
+            <a:ext cx="1980590" cy="274320"/>
+          </a:xfrm>
+          <a:prstGeom xmlns:a="http://schemas.openxmlformats.org/drawingml/2006/main" prst="rect">
+            <a:avLst/>
+          </a:prstGeom>
+          <a:noFill xmlns:a="http://schemas.openxmlformats.org/drawingml/2006/main"/>
+        </p:spPr>
+        <p:txBody>
+          <a:bodyPr xmlns:a="http://schemas.openxmlformats.org/drawingml/2006/main" wrap="square" lIns="0" tIns="0" rIns="0" bIns="0" anchor="ctr"/>
+          <a:lstStyle xmlns:a="http://schemas.openxmlformats.org/drawingml/2006/main"/>
+          <a:p xmlns:a="http://schemas.openxmlformats.org/drawingml/2006/main">
+            <a:pPr marL="0" indent="0" algn="ctr">
+              <a:buNone/>
+            </a:pPr>
+            <a:r>
+              <a:rPr sz="1300" b="1">
+                <a:solidFill>
+                  <a:srgbClr val="1A1A1A"/>
+                </a:solidFill>
+                <a:latin typeface="Arial"/>
+                <a:ea typeface="Arial"/>
+                <a:cs typeface="Arial"/>
+              </a:rPr>
+              <a:t>Interoperability</a:t>
+            </a:r>
+            <a:endParaRPr sz="1300"/>
+          </a:p>
+        </p:txBody>
+      </p:sp>
+      <p:sp>
+        <p:nvSpPr>
+          <p:cNvPr id="94" name="Text 18"/>
+          <p:cNvSpPr>
+            <a:spLocks xmlns:a="http://schemas.openxmlformats.org/drawingml/2006/main" noGrp="1"/>
+          </p:cNvSpPr>
+          <p:nvPr/>
+        </p:nvSpPr>
+        <p:spPr>
+          <a:xfrm xmlns:a="http://schemas.openxmlformats.org/drawingml/2006/main">
+            <a:off x="9687152" y="5486400"/>
+            <a:ext cx="1907438" cy="594360"/>
+          </a:xfrm>
+          <a:prstGeom xmlns:a="http://schemas.openxmlformats.org/drawingml/2006/main" prst="rect">
+            <a:avLst/>
+          </a:prstGeom>
+          <a:noFill xmlns:a="http://schemas.openxmlformats.org/drawingml/2006/main"/>
+        </p:spPr>
+        <p:txBody>
+          <a:bodyPr xmlns:a="http://schemas.openxmlformats.org/drawingml/2006/main" wrap="square" lIns="0" tIns="0" rIns="0" bIns="0" anchor="ctr">
+            <a:noAutofit/>
+          </a:bodyPr>
+          <a:lstStyle xmlns:a="http://schemas.openxmlformats.org/drawingml/2006/main"/>
+          <a:p xmlns:a="http://schemas.openxmlformats.org/drawingml/2006/main">
+            <a:pPr algn="ctr">
+              <a:spcBef>
+                <a:spcPts val="0"/>
+              </a:spcBef>
+              <a:spcAft>
+                <a:spcPts val="0"/>
+              </a:spcAft>
+              <a:buNone/>
+              <a:defRPr sz="1000">
+                <a:solidFill>
+                  <a:srgbClr val="666666"/>
+                </a:solidFill>
+                <a:latin typeface="Arial"/>
+                <a:ea typeface="Arial"/>
+                <a:cs typeface="Arial"/>
+              </a:defRPr>
+            </a:pPr>
+            <a:r>
+              <a:rPr sz="1000">
+                <a:solidFill>
+                  <a:srgbClr val="666666"/>
+                </a:solidFill>
+                <a:latin typeface="Arial"/>
+                <a:ea typeface="Arial"/>
+                <a:cs typeface="Arial"/>
+              </a:rPr>
+              <a:t>matchms · spectrum_utils</a:t>
+            </a:r>
+          </a:p>
+          <a:p xmlns:a="http://schemas.openxmlformats.org/drawingml/2006/main">
+            <a:pPr algn="ctr">
+              <a:spcBef>
+                <a:spcPts val="0"/>
+              </a:spcBef>
+              <a:spcAft>
+                <a:spcPts val="0"/>
+              </a:spcAft>
+              <a:buNone/>
+              <a:defRPr sz="1000">
+                <a:solidFill>
+                  <a:srgbClr val="666666"/>
+                </a:solidFill>
+                <a:latin typeface="Arial"/>
+                <a:ea typeface="Arial"/>
+                <a:cs typeface="Arial"/>
+              </a:defRPr>
+            </a:pPr>
+            <a:r>
+              <a:rPr sz="1000">
+                <a:solidFill>
+                  <a:srgbClr val="666666"/>
+                </a:solidFill>
+                <a:latin typeface="Arial"/>
+                <a:ea typeface="Arial"/>
+                <a:cs typeface="Arial"/>
+              </a:rPr>
+              <a:t>spectrl URL-safe tokens</a:t>
             </a:r>
           </a:p>
         </p:txBody>
@@ -2900,7 +3014,7 @@
         </p:nvSpPr>
         <p:spPr>
           <a:xfrm xmlns:a="http://schemas.openxmlformats.org/drawingml/2006/main">
-            <a:off x="502920" y="6263640"/>
+            <a:off x="502920" y="6428232"/>
             <a:ext cx="11183112" cy="274320"/>
           </a:xfrm>
           <a:prstGeom xmlns:a="http://schemas.openxmlformats.org/drawingml/2006/main" prst="rect">

</xml_diff>